<commit_message>
Beta V1.43.5 QR working in new server
</commit_message>
<xml_diff>
--- a/backend/storage/app/Templates/QR template.pptx
+++ b/backend/storage/app/Templates/QR template.pptx
@@ -197,7 +197,7 @@
           <a:p>
             <a:fld id="{404309B4-38A1-4E09-8C30-663C85214DDB}" type="datetimeFigureOut">
               <a:rPr lang="fr-MA" smtClean="0"/>
-              <a:t>14/03/2026</a:t>
+              <a:t>16/03/2026</a:t>
             </a:fld>
             <a:endParaRPr lang="fr-MA"/>
           </a:p>
@@ -704,7 +704,7 @@
           <a:p>
             <a:fld id="{DB06CA5D-EE84-4C01-B57D-41C38433FB48}" type="datetimeFigureOut">
               <a:rPr lang="fr-MA" smtClean="0"/>
-              <a:t>14/03/2026</a:t>
+              <a:t>16/03/2026</a:t>
             </a:fld>
             <a:endParaRPr lang="fr-MA"/>
           </a:p>
@@ -874,7 +874,7 @@
           <a:p>
             <a:fld id="{DB06CA5D-EE84-4C01-B57D-41C38433FB48}" type="datetimeFigureOut">
               <a:rPr lang="fr-MA" smtClean="0"/>
-              <a:t>14/03/2026</a:t>
+              <a:t>16/03/2026</a:t>
             </a:fld>
             <a:endParaRPr lang="fr-MA"/>
           </a:p>
@@ -1054,7 +1054,7 @@
           <a:p>
             <a:fld id="{DB06CA5D-EE84-4C01-B57D-41C38433FB48}" type="datetimeFigureOut">
               <a:rPr lang="fr-MA" smtClean="0"/>
-              <a:t>14/03/2026</a:t>
+              <a:t>16/03/2026</a:t>
             </a:fld>
             <a:endParaRPr lang="fr-MA"/>
           </a:p>
@@ -1224,7 +1224,7 @@
           <a:p>
             <a:fld id="{DB06CA5D-EE84-4C01-B57D-41C38433FB48}" type="datetimeFigureOut">
               <a:rPr lang="fr-MA" smtClean="0"/>
-              <a:t>14/03/2026</a:t>
+              <a:t>16/03/2026</a:t>
             </a:fld>
             <a:endParaRPr lang="fr-MA"/>
           </a:p>
@@ -1470,7 +1470,7 @@
           <a:p>
             <a:fld id="{DB06CA5D-EE84-4C01-B57D-41C38433FB48}" type="datetimeFigureOut">
               <a:rPr lang="fr-MA" smtClean="0"/>
-              <a:t>14/03/2026</a:t>
+              <a:t>16/03/2026</a:t>
             </a:fld>
             <a:endParaRPr lang="fr-MA"/>
           </a:p>
@@ -1702,7 +1702,7 @@
           <a:p>
             <a:fld id="{DB06CA5D-EE84-4C01-B57D-41C38433FB48}" type="datetimeFigureOut">
               <a:rPr lang="fr-MA" smtClean="0"/>
-              <a:t>14/03/2026</a:t>
+              <a:t>16/03/2026</a:t>
             </a:fld>
             <a:endParaRPr lang="fr-MA"/>
           </a:p>
@@ -2069,7 +2069,7 @@
           <a:p>
             <a:fld id="{DB06CA5D-EE84-4C01-B57D-41C38433FB48}" type="datetimeFigureOut">
               <a:rPr lang="fr-MA" smtClean="0"/>
-              <a:t>14/03/2026</a:t>
+              <a:t>16/03/2026</a:t>
             </a:fld>
             <a:endParaRPr lang="fr-MA"/>
           </a:p>
@@ -2187,7 +2187,7 @@
           <a:p>
             <a:fld id="{DB06CA5D-EE84-4C01-B57D-41C38433FB48}" type="datetimeFigureOut">
               <a:rPr lang="fr-MA" smtClean="0"/>
-              <a:t>14/03/2026</a:t>
+              <a:t>16/03/2026</a:t>
             </a:fld>
             <a:endParaRPr lang="fr-MA"/>
           </a:p>
@@ -2282,7 +2282,7 @@
           <a:p>
             <a:fld id="{DB06CA5D-EE84-4C01-B57D-41C38433FB48}" type="datetimeFigureOut">
               <a:rPr lang="fr-MA" smtClean="0"/>
-              <a:t>14/03/2026</a:t>
+              <a:t>16/03/2026</a:t>
             </a:fld>
             <a:endParaRPr lang="fr-MA"/>
           </a:p>
@@ -2559,7 +2559,7 @@
           <a:p>
             <a:fld id="{DB06CA5D-EE84-4C01-B57D-41C38433FB48}" type="datetimeFigureOut">
               <a:rPr lang="fr-MA" smtClean="0"/>
-              <a:t>14/03/2026</a:t>
+              <a:t>16/03/2026</a:t>
             </a:fld>
             <a:endParaRPr lang="fr-MA"/>
           </a:p>
@@ -2816,7 +2816,7 @@
           <a:p>
             <a:fld id="{DB06CA5D-EE84-4C01-B57D-41C38433FB48}" type="datetimeFigureOut">
               <a:rPr lang="fr-MA" smtClean="0"/>
-              <a:t>14/03/2026</a:t>
+              <a:t>16/03/2026</a:t>
             </a:fld>
             <a:endParaRPr lang="fr-MA"/>
           </a:p>
@@ -3029,7 +3029,7 @@
           <a:p>
             <a:fld id="{DB06CA5D-EE84-4C01-B57D-41C38433FB48}" type="datetimeFigureOut">
               <a:rPr lang="fr-MA" smtClean="0"/>
-              <a:t>14/03/2026</a:t>
+              <a:t>16/03/2026</a:t>
             </a:fld>
             <a:endParaRPr lang="fr-MA"/>
           </a:p>
@@ -3928,8 +3928,8 @@
         </p:nvSpPr>
         <p:spPr>
           <a:xfrm>
-            <a:off x="178529" y="5456021"/>
-            <a:ext cx="4527612" cy="400110"/>
+            <a:off x="249608" y="5609942"/>
+            <a:ext cx="4385454" cy="369332"/>
           </a:xfrm>
           <a:prstGeom prst="rect">
             <a:avLst/>
@@ -3944,44 +3944,44 @@
           <a:p>
             <a:pPr algn="ctr"/>
             <a:r>
-              <a:rPr lang="fr-MA" sz="2000" b="1" dirty="0">
+              <a:rPr lang="fr-MA" b="1" dirty="0">
                 <a:effectLst>
-                  <a:outerShdw blurRad="38100" dist="38100" dir="2700000" algn="tl">
+                  <a:outerShdw blurRad="38100" dist="38100" dir="2700000" algn="tl" rotWithShape="0">
                     <a:srgbClr val="000000">
-                      <a:alpha val="43137"/>
+                      <a:alpha val="43000"/>
                     </a:srgbClr>
                   </a:outerShdw>
                 </a:effectLst>
-                <a:latin typeface="Bahnschrift SemiCondensed" panose="020B0502040204020203" pitchFamily="34" charset="0"/>
               </a:rPr>
               <a:t>(</a:t>
             </a:r>
             <a:r>
-              <a:rPr lang="fr-MA" sz="2000" b="1" dirty="0" err="1">
+              <a:rPr lang="fr-MA" b="1" dirty="0" err="1">
                 <a:effectLst>
-                  <a:outerShdw blurRad="38100" dist="38100" dir="2700000" algn="tl">
+                  <a:outerShdw blurRad="38100" dist="38100" dir="2700000" algn="tl" rotWithShape="0">
                     <a:srgbClr val="000000">
-                      <a:alpha val="43137"/>
+                      <a:alpha val="43000"/>
                     </a:srgbClr>
                   </a:outerShdw>
                 </a:effectLst>
-                <a:latin typeface="Bahnschrift SemiCondensed" panose="020B0502040204020203" pitchFamily="34" charset="0"/>
               </a:rPr>
               <a:t>product_name</a:t>
             </a:r>
             <a:r>
-              <a:rPr lang="fr-MA" sz="2000" b="1" dirty="0">
+              <a:rPr lang="fr-MA" b="1" dirty="0">
                 <a:effectLst>
-                  <a:outerShdw blurRad="38100" dist="38100" dir="2700000" algn="tl">
+                  <a:outerShdw blurRad="38100" dist="38100" dir="2700000" algn="tl" rotWithShape="0">
                     <a:srgbClr val="000000">
-                      <a:alpha val="43137"/>
+                      <a:alpha val="43000"/>
                     </a:srgbClr>
                   </a:outerShdw>
                 </a:effectLst>
-                <a:latin typeface="Bahnschrift SemiCondensed" panose="020B0502040204020203" pitchFamily="34" charset="0"/>
               </a:rPr>
               <a:t>)</a:t>
             </a:r>
+            <a:endParaRPr lang="fr-MA" sz="2000" dirty="0">
+              <a:effectLst/>
+            </a:endParaRPr>
           </a:p>
         </p:txBody>
       </p:sp>
@@ -3999,8 +3999,8 @@
         </p:nvSpPr>
         <p:spPr>
           <a:xfrm>
-            <a:off x="260498" y="6019800"/>
-            <a:ext cx="4363674" cy="656880"/>
+            <a:off x="260498" y="6132786"/>
+            <a:ext cx="4363674" cy="575425"/>
           </a:xfrm>
           <a:prstGeom prst="rect">
             <a:avLst/>

</xml_diff>